<commit_message>
bench(qp): Maros-Meszaros on main at 847042e3, 108 matched and 119 verified of 138
All 138 instances at 60 s on the laptop, the binary built from main at 847042e3
(bench/results/maros-meszaros-847042e3.csv): optimal on 109, within 1e-6 of the
reference on 108, verifier-accepted on 119, no optimal the verifier rejects.
Against the README's 9094e1c run (106 / 106 / 120): powell20, primalc1, qcapri and
qshare1b are gained by the refined Newton step of #1010; boyd2 and cont-300 are lost
to the 60 s limit at 0 and 11 iterations on a laptop that had other builds running
(the quiet 9094e1c run solved them in 36 s and 31 s; boyd1 took 55 s here against
19 s there, the same slowdown).

docs/BENCHMARKS.md and docs/REPORT.md regenerated from the CSVs by their scripts;
the README's Maros-Meszaros row and paragraph updated to this run.

Refs #980, #981.
</commit_message>
<xml_diff>
--- a/docs/SANKHYA-deck.pptx
+++ b/docs/SANKHYA-deck.pptx
@@ -3896,7 +3896,7 @@
                   <a:srgbClr val="555555"/>
                 </a:solidFill>
               </a:rPr>
-              <a:t>Declined instances: stress set 15 of 126 declined (0 wrong); Maros-Meszaros 106 of 138 optimal; safe bounds, 18 of 93 optimal answers with no finite bound, and they say so.</a:t>
+              <a:t>Declined instances: stress set 15 of 126 declined (0 wrong); Maros-Meszaros 109 of 138 optimal; safe bounds, 18 of 93 optimal answers with no finite bound, and they say so.</a:t>
             </a:r>
           </a:p>
           <a:p>
@@ -8996,7 +8996,7 @@
                   <a:srgbClr val="555555"/>
                 </a:solidFill>
               </a:rPr>
-              <a:t>Source: bench/results/head-to-head-maros-meszaros-1860864.csv (1860864); bench/results/maros-meszaros-9094e1c.csv (9094e1c); bench/results/miplib-ad57c03.csv (ad57c03)</a:t>
+              <a:t>Source: bench/results/head-to-head-maros-meszaros-1860864.csv (1860864); bench/results/maros-meszaros-847042e3.csv (847042e3); bench/results/miplib-ad57c03.csv (ad57c03)</a:t>
             </a:r>
           </a:p>
         </p:txBody>
@@ -9885,7 +9885,7 @@
                   <a:srgbClr val="555555"/>
                 </a:solidFill>
               </a:rPr>
-              <a:t>Alone, on the laptop: 106 of 138 at the published objective, 0 optimal answers rejected (bench/results/maros-meszaros-9094e1c.csv).</a:t>
+              <a:t>Alone, on the laptop: 108 of 138 at the published objective, 0 optimal answers rejected (bench/results/maros-meszaros-847042e3.csv).</a:t>
             </a:r>
           </a:p>
         </p:txBody>

</xml_diff>

<commit_message>
bench(qp): Maros-Meszaros on main at 847042e3, 108 matched and 119 verified of 138 (#1015)
All 138 at 60 s on the laptop with the binary built from main at 847042e3: optimal on 109, within 1e-6 of the reference on 108, verifier-accepted on 119, no optimal the verifier rejects. Gained against 9094e1c: powell20, primalc1, qcapri, qshare1b (#1010); boyd2 and cont-300 lost to the 60 s limit on a loaded laptop. BENCHMARKS.md and REPORT.md regenerated, README updated. Refs #980, #981.
</commit_message>
<xml_diff>
--- a/docs/SANKHYA-deck.pptx
+++ b/docs/SANKHYA-deck.pptx
@@ -3896,7 +3896,7 @@
                   <a:srgbClr val="555555"/>
                 </a:solidFill>
               </a:rPr>
-              <a:t>Declined instances: stress set 15 of 126 declined (0 wrong); Maros-Meszaros 106 of 138 optimal; safe bounds, 18 of 93 optimal answers with no finite bound, and they say so.</a:t>
+              <a:t>Declined instances: stress set 15 of 126 declined (0 wrong); Maros-Meszaros 109 of 138 optimal; safe bounds, 18 of 93 optimal answers with no finite bound, and they say so.</a:t>
             </a:r>
           </a:p>
           <a:p>
@@ -8996,7 +8996,7 @@
                   <a:srgbClr val="555555"/>
                 </a:solidFill>
               </a:rPr>
-              <a:t>Source: bench/results/head-to-head-maros-meszaros-1860864.csv (1860864); bench/results/maros-meszaros-9094e1c.csv (9094e1c); bench/results/miplib-ad57c03.csv (ad57c03)</a:t>
+              <a:t>Source: bench/results/head-to-head-maros-meszaros-1860864.csv (1860864); bench/results/maros-meszaros-847042e3.csv (847042e3); bench/results/miplib-ad57c03.csv (ad57c03)</a:t>
             </a:r>
           </a:p>
         </p:txBody>
@@ -9885,7 +9885,7 @@
                   <a:srgbClr val="555555"/>
                 </a:solidFill>
               </a:rPr>
-              <a:t>Alone, on the laptop: 106 of 138 at the published objective, 0 optimal answers rejected (bench/results/maros-meszaros-9094e1c.csv).</a:t>
+              <a:t>Alone, on the laptop: 108 of 138 at the published objective, 0 optimal answers rejected (bench/results/maros-meszaros-847042e3.csv).</a:t>
             </a:r>
           </a:p>
         </p:txBody>

</xml_diff>

<commit_message>
bench(netlib): certified gaps on the full set at 44418e2b, 90 of 94 optimal answers certified to 1e-6
Laptop run, timings not used anywhere; the count is the headline. 94 of 94
optimal and verified; 90 within 1e-6 relative of their Neumaier-Shcherbina
bound (worst 5.1e-08), pilot87 at 4.1e-06 (its exact duals ran past the
30 s budget after a 48 s solve), greenbea, greenbeb and maros-r7 with no
finite bound. BENCHMARKS 1c.2, the README scoreboard row and the jury
report are regenerated from the CSV.

Refs #763
</commit_message>
<xml_diff>
--- a/docs/SANKHYA-deck.pptx
+++ b/docs/SANKHYA-deck.pptx
@@ -3813,7 +3813,7 @@
                   <a:srgbClr val="555555"/>
                 </a:solidFill>
               </a:rPr>
-              <a:t>Source: bench/results/head-to-head-netlib-5e490ef.csv; bench/results/head-to-head-kennington-1860864.csv; bench/results/mittelmann-72123ff.csv; bench/results/miplib-ad57c03.csv; bench/results/stress-d32b3847.csv; bench/results/certified-gap-netlib-full-0134c92.csv; docs/NEGATIVE-RESULTS.md</a:t>
+              <a:t>Source: bench/results/head-to-head-netlib-5e490ef.csv; bench/results/head-to-head-kennington-1860864.csv; bench/results/mittelmann-72123ff.csv; bench/results/miplib-ad57c03.csv; bench/results/stress-d32b3847.csv; bench/results/certified-gap-netlib-full-44418e2b.csv; docs/NEGATIVE-RESULTS.md</a:t>
             </a:r>
           </a:p>
         </p:txBody>
@@ -3896,7 +3896,7 @@
                   <a:srgbClr val="555555"/>
                 </a:solidFill>
               </a:rPr>
-              <a:t>Declined instances: stress set 15 of 126 declined (0 wrong); Maros-Meszaros 106 of 138 optimal; safe bounds, 18 of 93 optimal answers with no finite bound, and they say so.</a:t>
+              <a:t>Declined instances: stress set 15 of 126 declined (0 wrong); Maros-Meszaros 106 of 138 optimal; safe bounds, 3 of 94 optimal answers with no finite bound, and they say so.</a:t>
             </a:r>
           </a:p>
           <a:p>
@@ -6548,7 +6548,7 @@
                   <a:srgbClr val="555555"/>
                 </a:solidFill>
               </a:rPr>
-              <a:t>Source: bench/results/netlib-full-9094e1c.csv, bench/results/netlib-infeasible-5a39fb2.csv, bench/results/certified-gap-netlib-full-0134c92.csv, bench/results/exact-sensitivity-60455ce.csv, bench/results/stress-d32b3847.csv</a:t>
+              <a:t>Source: bench/results/netlib-full-9094e1c.csv, bench/results/netlib-infeasible-5a39fb2.csv, bench/results/certified-gap-netlib-full-44418e2b.csv, bench/results/exact-sensitivity-60455ce.csv, bench/results/stress-d32b3847.csv</a:t>
             </a:r>
           </a:p>
         </p:txBody>
@@ -6954,7 +6954,7 @@
                             <a:srgbClr val="555555"/>
                           </a:solidFill>
                         </a:rPr>
-                        <a:t>73 of 93</a:t>
+                        <a:t>90 of 94</a:t>
                       </a:r>
                     </a:p>
                   </a:txBody>
@@ -6975,7 +6975,7 @@
                             <a:srgbClr val="555555"/>
                           </a:solidFill>
                         </a:rPr>
-                        <a:t>bench/results/certified-gap-netlib-full-0134c92.csv</a:t>
+                        <a:t>bench/results/certified-gap-netlib-full-44418e2b.csv</a:t>
                       </a:r>
                     </a:p>
                   </a:txBody>
@@ -6996,7 +6996,7 @@
                             <a:srgbClr val="555555"/>
                           </a:solidFill>
                         </a:rPr>
-                        <a:t>0134c92</a:t>
+                        <a:t>44418e2b</a:t>
                       </a:r>
                     </a:p>
                   </a:txBody>

</xml_diff>

<commit_message>
docs(report): regenerate the jury report and scoreboard on the merged history
The merge's regeneration ran before the merge commit existed, so main's
Maros-Meszaros CSV was not yet in git log and the older one was chosen.
</commit_message>
<xml_diff>
--- a/docs/SANKHYA-deck.pptx
+++ b/docs/SANKHYA-deck.pptx
@@ -3896,7 +3896,7 @@
                   <a:srgbClr val="555555"/>
                 </a:solidFill>
               </a:rPr>
-              <a:t>Declined instances: stress set 15 of 126 declined (0 wrong); Maros-Meszaros 106 of 138 optimal; safe bounds, 3 of 94 optimal answers with no finite bound, and they say so.</a:t>
+              <a:t>Declined instances: stress set 15 of 126 declined (0 wrong); Maros-Meszaros 109 of 138 optimal; safe bounds, 3 of 94 optimal answers with no finite bound, and they say so.</a:t>
             </a:r>
           </a:p>
           <a:p>
@@ -8996,7 +8996,7 @@
                   <a:srgbClr val="555555"/>
                 </a:solidFill>
               </a:rPr>
-              <a:t>Source: bench/results/head-to-head-maros-meszaros-1860864.csv (1860864); bench/results/maros-meszaros-9094e1c.csv (9094e1c); bench/results/miplib-ad57c03.csv (ad57c03)</a:t>
+              <a:t>Source: bench/results/head-to-head-maros-meszaros-1860864.csv (1860864); bench/results/maros-meszaros-847042e3.csv (847042e3); bench/results/miplib-ad57c03.csv (ad57c03)</a:t>
             </a:r>
           </a:p>
         </p:txBody>
@@ -9885,7 +9885,7 @@
                   <a:srgbClr val="555555"/>
                 </a:solidFill>
               </a:rPr>
-              <a:t>Alone, on the laptop: 106 of 138 at the published objective, 0 optimal answers rejected (bench/results/maros-meszaros-9094e1c.csv).</a:t>
+              <a:t>Alone, on the laptop: 108 of 138 at the published objective, 0 optimal answers rejected (bench/results/maros-meszaros-847042e3.csv).</a:t>
             </a:r>
           </a:p>
         </p:txBody>

</xml_diff>

<commit_message>
bench(qp): Maros-Meszaros on main at 2a3e303d, 112 matched and 124 verified of 138
All 138 instances at 60 s on the laptop, the binary built from main at 2a3e303d with
the new defaults of #1016 (bench/results/maros-meszaros-2a3e303d.csv): optimal on 114,
within 1e-6 of the reference on 112, verifier-accepted on 124, no optimal the verifier
rejects. Against the 847042e3 run (108 / 119 / 109): ubh1 is gained by the stall
hand-off now on by default; boyd2, cont-300 and cvxqp2l by a quieter machine (each at
the 60 s limit there, 69, 13 and 18 iterations here); nothing lost. Five instances end
at the limit: cvxqp1l, cvxqp3l, liswet7, qsierra, stadat1.

docs/BENCHMARKS.md and docs/REPORT.md regenerated by their scripts; the README's
Maros-Meszaros row and paragraph updated to this run, with the 26 that remain named by
class.

Refs #980, #981.
</commit_message>
<xml_diff>
--- a/docs/SANKHYA-deck.pptx
+++ b/docs/SANKHYA-deck.pptx
@@ -3896,7 +3896,7 @@
                   <a:srgbClr val="555555"/>
                 </a:solidFill>
               </a:rPr>
-              <a:t>Declined instances: stress set 15 of 126 declined (0 wrong); Maros-Meszaros 109 of 138 optimal; safe bounds, 18 of 93 optimal answers with no finite bound, and they say so.</a:t>
+              <a:t>Declined instances: stress set 15 of 126 declined (0 wrong); Maros-Meszaros 114 of 138 optimal; safe bounds, 18 of 93 optimal answers with no finite bound, and they say so.</a:t>
             </a:r>
           </a:p>
           <a:p>
@@ -8996,7 +8996,7 @@
                   <a:srgbClr val="555555"/>
                 </a:solidFill>
               </a:rPr>
-              <a:t>Source: bench/results/head-to-head-maros-meszaros-1860864.csv (1860864); bench/results/maros-meszaros-847042e3.csv (847042e3); bench/results/miplib-ad57c03.csv (ad57c03)</a:t>
+              <a:t>Source: bench/results/head-to-head-maros-meszaros-1860864.csv (1860864); bench/results/maros-meszaros-2a3e303d.csv (2a3e303d); bench/results/miplib-ad57c03.csv (ad57c03)</a:t>
             </a:r>
           </a:p>
         </p:txBody>
@@ -9885,7 +9885,7 @@
                   <a:srgbClr val="555555"/>
                 </a:solidFill>
               </a:rPr>
-              <a:t>Alone, on the laptop: 108 of 138 at the published objective, 0 optimal answers rejected (bench/results/maros-meszaros-847042e3.csv).</a:t>
+              <a:t>Alone, on the laptop: 112 of 138 at the published objective, 0 optimal answers rejected (bench/results/maros-meszaros-2a3e303d.csv).</a:t>
             </a:r>
           </a:p>
         </p:txBody>

</xml_diff>

<commit_message>
bench(netlib): the certified-gap CSV follows in a run stamped on main (#433)
The branch-stamped run stays in the PR description as this session's
measurement; the committed CSV is produced on the squash commit.
</commit_message>
<xml_diff>
--- a/docs/SANKHYA-deck.pptx
+++ b/docs/SANKHYA-deck.pptx
@@ -3813,7 +3813,7 @@
                   <a:srgbClr val="555555"/>
                 </a:solidFill>
               </a:rPr>
-              <a:t>Source: bench/results/head-to-head-netlib-5e490ef.csv; bench/results/head-to-head-kennington-1860864.csv; bench/results/mittelmann-72123ff.csv; bench/results/miplib-ad57c03.csv; bench/results/stress-d32b3847.csv; bench/results/certified-gap-netlib-full-44418e2b.csv; docs/NEGATIVE-RESULTS.md</a:t>
+              <a:t>Source: bench/results/head-to-head-netlib-5e490ef.csv; bench/results/head-to-head-kennington-1860864.csv; bench/results/mittelmann-72123ff.csv; bench/results/miplib-ad57c03.csv; bench/results/stress-d32b3847.csv; bench/results/certified-gap-netlib-full-0134c92.csv; docs/NEGATIVE-RESULTS.md</a:t>
             </a:r>
           </a:p>
         </p:txBody>
@@ -3896,7 +3896,7 @@
                   <a:srgbClr val="555555"/>
                 </a:solidFill>
               </a:rPr>
-              <a:t>Declined instances: stress set 15 of 126 declined (0 wrong); Maros-Meszaros 109 of 138 optimal; safe bounds, 3 of 94 optimal answers with no finite bound, and they say so.</a:t>
+              <a:t>Declined instances: stress set 15 of 126 declined (0 wrong); Maros-Meszaros 109 of 138 optimal; safe bounds, 18 of 93 optimal answers with no finite bound, and they say so.</a:t>
             </a:r>
           </a:p>
           <a:p>
@@ -6548,7 +6548,7 @@
                   <a:srgbClr val="555555"/>
                 </a:solidFill>
               </a:rPr>
-              <a:t>Source: bench/results/netlib-full-9094e1c.csv, bench/results/netlib-infeasible-5a39fb2.csv, bench/results/certified-gap-netlib-full-44418e2b.csv, bench/results/exact-sensitivity-60455ce.csv, bench/results/stress-d32b3847.csv</a:t>
+              <a:t>Source: bench/results/netlib-full-9094e1c.csv, bench/results/netlib-infeasible-5a39fb2.csv, bench/results/certified-gap-netlib-full-0134c92.csv, bench/results/exact-sensitivity-60455ce.csv, bench/results/stress-d32b3847.csv</a:t>
             </a:r>
           </a:p>
         </p:txBody>
@@ -6954,7 +6954,7 @@
                             <a:srgbClr val="555555"/>
                           </a:solidFill>
                         </a:rPr>
-                        <a:t>90 of 94</a:t>
+                        <a:t>73 of 93</a:t>
                       </a:r>
                     </a:p>
                   </a:txBody>
@@ -6975,7 +6975,7 @@
                             <a:srgbClr val="555555"/>
                           </a:solidFill>
                         </a:rPr>
-                        <a:t>bench/results/certified-gap-netlib-full-44418e2b.csv</a:t>
+                        <a:t>bench/results/certified-gap-netlib-full-0134c92.csv</a:t>
                       </a:r>
                     </a:p>
                   </a:txBody>
@@ -6996,7 +6996,7 @@
                             <a:srgbClr val="555555"/>
                           </a:solidFill>
                         </a:rPr>
-                        <a:t>44418e2b</a:t>
+                        <a:t>0134c92</a:t>
                       </a:r>
                     </a:p>
                   </a:txBody>

</xml_diff>

<commit_message>
bench(netlib): certified gaps on the full set at 736a1106, 90 of 94 optimal answers certified to 1e-6
The run on main after #1017: 94 of 94 optimal and verified, 90 within 1e-6
relative of the Neumaier-Shcherbina bound of their own duals (worst
5.1e-08), every stated bound re-derived exactly by tools/verify_solution.py.
pilot87 is finite but looser (6.3e-06); greenbea, greenbeb and maros-r7
have no finite bound. Laptop run: the timings are not used anywhere, the
count is the headline. BENCHMARKS 1c.2, the README scoreboard row and the
jury report are regenerated from the CSV by their scripts.

Refs #763
</commit_message>
<xml_diff>
--- a/docs/SANKHYA-deck.pptx
+++ b/docs/SANKHYA-deck.pptx
@@ -3813,7 +3813,7 @@
                   <a:srgbClr val="555555"/>
                 </a:solidFill>
               </a:rPr>
-              <a:t>Source: bench/results/head-to-head-netlib-5e490ef.csv; bench/results/head-to-head-kennington-1860864.csv; bench/results/mittelmann-72123ff.csv; bench/results/miplib-ad57c03.csv; bench/results/stress-d32b3847.csv; bench/results/certified-gap-netlib-full-0134c92.csv; docs/NEGATIVE-RESULTS.md</a:t>
+              <a:t>Source: bench/results/head-to-head-netlib-5e490ef.csv; bench/results/head-to-head-kennington-1860864.csv; bench/results/mittelmann-72123ff.csv; bench/results/miplib-ad57c03.csv; bench/results/stress-d32b3847.csv; bench/results/certified-gap-netlib-full-736a1106.csv; docs/NEGATIVE-RESULTS.md</a:t>
             </a:r>
           </a:p>
         </p:txBody>
@@ -3896,7 +3896,7 @@
                   <a:srgbClr val="555555"/>
                 </a:solidFill>
               </a:rPr>
-              <a:t>Declined instances: stress set 15 of 126 declined (0 wrong); Maros-Meszaros 109 of 138 optimal; safe bounds, 18 of 93 optimal answers with no finite bound, and they say so.</a:t>
+              <a:t>Declined instances: stress set 15 of 126 declined (0 wrong); Maros-Meszaros 109 of 138 optimal; safe bounds, 3 of 94 optimal answers with no finite bound, and they say so.</a:t>
             </a:r>
           </a:p>
           <a:p>
@@ -6548,7 +6548,7 @@
                   <a:srgbClr val="555555"/>
                 </a:solidFill>
               </a:rPr>
-              <a:t>Source: bench/results/netlib-full-9094e1c.csv, bench/results/netlib-infeasible-5a39fb2.csv, bench/results/certified-gap-netlib-full-0134c92.csv, bench/results/exact-sensitivity-60455ce.csv, bench/results/stress-d32b3847.csv</a:t>
+              <a:t>Source: bench/results/netlib-full-9094e1c.csv, bench/results/netlib-infeasible-5a39fb2.csv, bench/results/certified-gap-netlib-full-736a1106.csv, bench/results/exact-sensitivity-60455ce.csv, bench/results/stress-d32b3847.csv</a:t>
             </a:r>
           </a:p>
         </p:txBody>
@@ -6954,7 +6954,7 @@
                             <a:srgbClr val="555555"/>
                           </a:solidFill>
                         </a:rPr>
-                        <a:t>73 of 93</a:t>
+                        <a:t>90 of 94</a:t>
                       </a:r>
                     </a:p>
                   </a:txBody>
@@ -6975,7 +6975,7 @@
                             <a:srgbClr val="555555"/>
                           </a:solidFill>
                         </a:rPr>
-                        <a:t>bench/results/certified-gap-netlib-full-0134c92.csv</a:t>
+                        <a:t>bench/results/certified-gap-netlib-full-736a1106.csv</a:t>
                       </a:r>
                     </a:p>
                   </a:txBody>
@@ -6996,7 +6996,7 @@
                             <a:srgbClr val="555555"/>
                           </a:solidFill>
                         </a:rPr>
-                        <a:t>0134c92</a:t>
+                        <a:t>736a1106</a:t>
                       </a:r>
                     </a:p>
                   </a:txBody>

</xml_diff>

<commit_message>
bench(qp): Maros-Meszaros on main at 2a3e303d, 112 matched and 124 verified of 138 (#1019)
All 138 at 60 s on the laptop, main at 2a3e303d with the #1016 defaults: optimal 114, within 1e-6 of the reference and verified 112, verifier-accepted 124, no optimal the verifier rejects. BENCHMARKS.md, REPORT.md, the README scoreboard and paragraph, and the PS26119 coverage line updated to this run. Refs #980, #981.
</commit_message>
<xml_diff>
--- a/docs/SANKHYA-deck.pptx
+++ b/docs/SANKHYA-deck.pptx
@@ -3896,7 +3896,7 @@
                   <a:srgbClr val="555555"/>
                 </a:solidFill>
               </a:rPr>
-              <a:t>Declined instances: stress set 15 of 126 declined (0 wrong); Maros-Meszaros 109 of 138 optimal; safe bounds, 18 of 93 optimal answers with no finite bound, and they say so.</a:t>
+              <a:t>Declined instances: stress set 15 of 126 declined (0 wrong); Maros-Meszaros 114 of 138 optimal; safe bounds, 18 of 93 optimal answers with no finite bound, and they say so.</a:t>
             </a:r>
           </a:p>
           <a:p>
@@ -8996,7 +8996,7 @@
                   <a:srgbClr val="555555"/>
                 </a:solidFill>
               </a:rPr>
-              <a:t>Source: bench/results/head-to-head-maros-meszaros-1860864.csv (1860864); bench/results/maros-meszaros-847042e3.csv (847042e3); bench/results/miplib-ad57c03.csv (ad57c03)</a:t>
+              <a:t>Source: bench/results/head-to-head-maros-meszaros-1860864.csv (1860864); bench/results/maros-meszaros-2a3e303d.csv (2a3e303d); bench/results/miplib-ad57c03.csv (ad57c03)</a:t>
             </a:r>
           </a:p>
         </p:txBody>
@@ -9885,7 +9885,7 @@
                   <a:srgbClr val="555555"/>
                 </a:solidFill>
               </a:rPr>
-              <a:t>Alone, on the laptop: 108 of 138 at the published objective, 0 optimal answers rejected (bench/results/maros-meszaros-847042e3.csv).</a:t>
+              <a:t>Alone, on the laptop: 112 of 138 at the published objective, 0 optimal answers rejected (bench/results/maros-meszaros-2a3e303d.csv).</a:t>
             </a:r>
           </a:p>
         </p:txBody>

</xml_diff>

<commit_message>
docs(report): regenerate the jury report, scoreboard and benchmarks on the merged history
</commit_message>
<xml_diff>
--- a/docs/SANKHYA-deck.pptx
+++ b/docs/SANKHYA-deck.pptx
@@ -3813,7 +3813,7 @@
                   <a:srgbClr val="555555"/>
                 </a:solidFill>
               </a:rPr>
-              <a:t>Source: bench/results/head-to-head-netlib-5e490ef.csv; bench/results/head-to-head-kennington-1860864.csv; bench/results/mittelmann-72123ff.csv; bench/results/miplib-ad57c03.csv; bench/results/stress-d32b3847.csv; bench/results/certified-gap-netlib-full-0134c92.csv; docs/NEGATIVE-RESULTS.md</a:t>
+              <a:t>Source: bench/results/head-to-head-netlib-5e490ef.csv; bench/results/head-to-head-kennington-1860864.csv; bench/results/mittelmann-72123ff.csv; bench/results/miplib-ad57c03.csv; bench/results/stress-d32b3847.csv; bench/results/certified-gap-netlib-full-736a1106.csv; docs/NEGATIVE-RESULTS.md</a:t>
             </a:r>
           </a:p>
         </p:txBody>
@@ -3896,7 +3896,7 @@
                   <a:srgbClr val="555555"/>
                 </a:solidFill>
               </a:rPr>
-              <a:t>Declined instances: stress set 15 of 126 declined (0 wrong); Maros-Meszaros 114 of 138 optimal; safe bounds, 18 of 93 optimal answers with no finite bound, and they say so.</a:t>
+              <a:t>Declined instances: stress set 15 of 126 declined (0 wrong); Maros-Meszaros 114 of 138 optimal; safe bounds, 3 of 94 optimal answers with no finite bound, and they say so.</a:t>
             </a:r>
           </a:p>
           <a:p>
@@ -6548,7 +6548,7 @@
                   <a:srgbClr val="555555"/>
                 </a:solidFill>
               </a:rPr>
-              <a:t>Source: bench/results/netlib-full-9094e1c.csv, bench/results/netlib-infeasible-5a39fb2.csv, bench/results/certified-gap-netlib-full-0134c92.csv, bench/results/exact-sensitivity-60455ce.csv, bench/results/stress-d32b3847.csv</a:t>
+              <a:t>Source: bench/results/netlib-full-9094e1c.csv, bench/results/netlib-infeasible-5a39fb2.csv, bench/results/certified-gap-netlib-full-736a1106.csv, bench/results/exact-sensitivity-60455ce.csv, bench/results/stress-d32b3847.csv</a:t>
             </a:r>
           </a:p>
         </p:txBody>
@@ -6954,7 +6954,7 @@
                             <a:srgbClr val="555555"/>
                           </a:solidFill>
                         </a:rPr>
-                        <a:t>73 of 93</a:t>
+                        <a:t>90 of 94</a:t>
                       </a:r>
                     </a:p>
                   </a:txBody>
@@ -6975,7 +6975,7 @@
                             <a:srgbClr val="555555"/>
                           </a:solidFill>
                         </a:rPr>
-                        <a:t>bench/results/certified-gap-netlib-full-0134c92.csv</a:t>
+                        <a:t>bench/results/certified-gap-netlib-full-736a1106.csv</a:t>
                       </a:r>
                     </a:p>
                   </a:txBody>
@@ -6996,7 +6996,7 @@
                             <a:srgbClr val="555555"/>
                           </a:solidFill>
                         </a:rPr>
-                        <a:t>0134c92</a:t>
+                        <a:t>736a1106</a:t>
                       </a:r>
                     </a:p>
                   </a:txBody>

</xml_diff>

<commit_message>
bench(netlib): certified gaps on the full set at 736a1106, 90 of 94 optimal answers certified to 1e-6 (#1021)
The run on main after #1017: 94 of 94 Netlib LPs optimal and verified, 90 within 1e-6 relative of the Neumaier-Shcherbina bound of their own duals (worst 5.1e-08), every stated bound re-derived exactly by tools/verify_solution.py. pilot87 is finite but looser (6.3e-06); greenbea, greenbeb and maros-r7 have no finite bound. Laptop run, so no timing from it is used; the count is the headline. The previous run read 73 of 93.

BENCHMARKS 1c.2, the README scoreboard (with the Netlib certified bounds row) and the jury report are regenerated from the CSVs on main by their scripts, including the Maros-Meszaros run of #1019.

Refs #763
</commit_message>
<xml_diff>
--- a/docs/SANKHYA-deck.pptx
+++ b/docs/SANKHYA-deck.pptx
@@ -3813,7 +3813,7 @@
                   <a:srgbClr val="555555"/>
                 </a:solidFill>
               </a:rPr>
-              <a:t>Source: bench/results/head-to-head-netlib-5e490ef.csv; bench/results/head-to-head-kennington-1860864.csv; bench/results/mittelmann-72123ff.csv; bench/results/miplib-ad57c03.csv; bench/results/stress-d32b3847.csv; bench/results/certified-gap-netlib-full-0134c92.csv; docs/NEGATIVE-RESULTS.md</a:t>
+              <a:t>Source: bench/results/head-to-head-netlib-5e490ef.csv; bench/results/head-to-head-kennington-1860864.csv; bench/results/mittelmann-72123ff.csv; bench/results/miplib-ad57c03.csv; bench/results/stress-d32b3847.csv; bench/results/certified-gap-netlib-full-736a1106.csv; docs/NEGATIVE-RESULTS.md</a:t>
             </a:r>
           </a:p>
         </p:txBody>
@@ -3896,7 +3896,7 @@
                   <a:srgbClr val="555555"/>
                 </a:solidFill>
               </a:rPr>
-              <a:t>Declined instances: stress set 15 of 126 declined (0 wrong); Maros-Meszaros 114 of 138 optimal; safe bounds, 18 of 93 optimal answers with no finite bound, and they say so.</a:t>
+              <a:t>Declined instances: stress set 15 of 126 declined (0 wrong); Maros-Meszaros 114 of 138 optimal; safe bounds, 3 of 94 optimal answers with no finite bound, and they say so.</a:t>
             </a:r>
           </a:p>
           <a:p>
@@ -6548,7 +6548,7 @@
                   <a:srgbClr val="555555"/>
                 </a:solidFill>
               </a:rPr>
-              <a:t>Source: bench/results/netlib-full-9094e1c.csv, bench/results/netlib-infeasible-5a39fb2.csv, bench/results/certified-gap-netlib-full-0134c92.csv, bench/results/exact-sensitivity-60455ce.csv, bench/results/stress-d32b3847.csv</a:t>
+              <a:t>Source: bench/results/netlib-full-9094e1c.csv, bench/results/netlib-infeasible-5a39fb2.csv, bench/results/certified-gap-netlib-full-736a1106.csv, bench/results/exact-sensitivity-60455ce.csv, bench/results/stress-d32b3847.csv</a:t>
             </a:r>
           </a:p>
         </p:txBody>
@@ -6954,7 +6954,7 @@
                             <a:srgbClr val="555555"/>
                           </a:solidFill>
                         </a:rPr>
-                        <a:t>73 of 93</a:t>
+                        <a:t>90 of 94</a:t>
                       </a:r>
                     </a:p>
                   </a:txBody>
@@ -6975,7 +6975,7 @@
                             <a:srgbClr val="555555"/>
                           </a:solidFill>
                         </a:rPr>
-                        <a:t>bench/results/certified-gap-netlib-full-0134c92.csv</a:t>
+                        <a:t>bench/results/certified-gap-netlib-full-736a1106.csv</a:t>
                       </a:r>
                     </a:p>
                   </a:txBody>
@@ -6996,7 +6996,7 @@
                             <a:srgbClr val="555555"/>
                           </a:solidFill>
                         </a:rPr>
-                        <a:t>0134c92</a:t>
+                        <a:t>736a1106</a:t>
                       </a:r>
                     </a:p>
                   </a:txBody>

</xml_diff>

<commit_message>
bench(qp): Maros-Meszaros on main at 8103fb18 under WSL, 109 matched and 121 verified of 138 (#1025)
All 138 at 60 s, main at 8103fb18 built with g++ 11.4 on Ubuntu 22.04 under WSL (4 vCPUs, 4 GB): optimal 111, within 1e-6 of the reference and verified 109, verifier-accepted 121, no optimal the verifier rejects. Supersedes the 2a3e303d, 847042e3 and finish-handoff-847042e3 CSVs, which were produced on Windows with relinked binaries of their commits; those stay as history and are no longer cited. boyd2, cont-300 and cvxqp2l hit the 60 s limit under WSL. BENCHMARKS.md, REPORT.md, the README scoreboard and paragraph and the PS26119 coverage line read this run. Refs #980, #981.
</commit_message>
<xml_diff>
--- a/docs/SANKHYA-deck.pptx
+++ b/docs/SANKHYA-deck.pptx
@@ -3896,7 +3896,7 @@
                   <a:srgbClr val="555555"/>
                 </a:solidFill>
               </a:rPr>
-              <a:t>Declined instances: stress set 15 of 126 declined (0 wrong); Maros-Meszaros 114 of 138 optimal; safe bounds, 3 of 94 optimal answers with no finite bound, and they say so.</a:t>
+              <a:t>Declined instances: stress set 15 of 126 declined (0 wrong); Maros-Meszaros 111 of 138 optimal; safe bounds, 3 of 94 optimal answers with no finite bound, and they say so.</a:t>
             </a:r>
           </a:p>
           <a:p>
@@ -8996,7 +8996,7 @@
                   <a:srgbClr val="555555"/>
                 </a:solidFill>
               </a:rPr>
-              <a:t>Source: bench/results/head-to-head-maros-meszaros-1860864.csv (1860864); bench/results/maros-meszaros-2a3e303d.csv (2a3e303d); bench/results/miplib-ad57c03.csv (ad57c03)</a:t>
+              <a:t>Source: bench/results/head-to-head-maros-meszaros-1860864.csv (1860864); bench/results/maros-meszaros-8103fb18.csv (8103fb18); bench/results/miplib-ad57c03.csv (ad57c03)</a:t>
             </a:r>
           </a:p>
         </p:txBody>
@@ -9885,7 +9885,7 @@
                   <a:srgbClr val="555555"/>
                 </a:solidFill>
               </a:rPr>
-              <a:t>Alone, on the laptop: 112 of 138 at the published objective, 0 optimal answers rejected (bench/results/maros-meszaros-2a3e303d.csv).</a:t>
+              <a:t>Alone, on the laptop: 109 of 138 at the published objective, 0 optimal answers rejected (bench/results/maros-meszaros-8103fb18.csv).</a:t>
             </a:r>
           </a:p>
         </p:txBody>

</xml_diff>

<commit_message>
bench(qp): Maros-Meszaros on main at dcbd32eb under WSL, 114 matched and 121 verified of 138 (#1032)
All 138 at 60 s, main at dcbd32eb built with g++ 11.4 on Ubuntu 22.04 under WSL (4 vCPUs, 4 GB): optimal 116, within 1e-6 of the reference and verified 114, verifier-accepted 121, no optimal the verifier rejects. Against the 8103fb18 run (109 / 121 / 111): boyd1, qgrow15, qseba, qship12l and qship12s gained by the rank-revealing finish of #1029, nothing lost; boyd2 and cont-300 at the 60 s limit on this VM; boyd1's finish 14 s past its limit inside one factorization, the next fix. BENCHMARKS.md, REPORT.md, the README scoreboard and paragraph and the PS26119 coverage line read this run. Refs #980, #981.
</commit_message>
<xml_diff>
--- a/docs/SANKHYA-deck.pptx
+++ b/docs/SANKHYA-deck.pptx
@@ -3896,7 +3896,7 @@
                   <a:srgbClr val="555555"/>
                 </a:solidFill>
               </a:rPr>
-              <a:t>Declined instances: stress set 15 of 126 declined (0 wrong); Maros-Meszaros 111 of 138 optimal; safe bounds, 3 of 94 optimal answers with no finite bound, and they say so.</a:t>
+              <a:t>Declined instances: stress set 15 of 126 declined (0 wrong); Maros-Meszaros 116 of 138 optimal; safe bounds, 3 of 94 optimal answers with no finite bound, and they say so.</a:t>
             </a:r>
           </a:p>
           <a:p>
@@ -8996,7 +8996,7 @@
                   <a:srgbClr val="555555"/>
                 </a:solidFill>
               </a:rPr>
-              <a:t>Source: bench/results/head-to-head-maros-meszaros-1860864.csv (1860864); bench/results/maros-meszaros-8103fb18.csv (8103fb18); bench/results/miplib-ad57c03.csv (ad57c03)</a:t>
+              <a:t>Source: bench/results/head-to-head-maros-meszaros-1860864.csv (1860864); bench/results/maros-meszaros-dcbd32eb.csv (dcbd32eb); bench/results/miplib-ad57c03.csv (ad57c03)</a:t>
             </a:r>
           </a:p>
         </p:txBody>
@@ -9885,7 +9885,7 @@
                   <a:srgbClr val="555555"/>
                 </a:solidFill>
               </a:rPr>
-              <a:t>Alone, on the laptop: 109 of 138 at the published objective, 0 optimal answers rejected (bench/results/maros-meszaros-8103fb18.csv).</a:t>
+              <a:t>Alone, on the laptop: 114 of 138 at the published objective, 0 optimal answers rejected (bench/results/maros-meszaros-dcbd32eb.csv).</a:t>
             </a:r>
           </a:p>
         </p:txBody>

</xml_diff>

<commit_message>
docs(report): REPORT.md, its PDF and the deck regenerated from the d0eb6729 head-to-head
</commit_message>
<xml_diff>
--- a/docs/SANKHYA-deck.pptx
+++ b/docs/SANKHYA-deck.pptx
@@ -8996,7 +8996,7 @@
                   <a:srgbClr val="555555"/>
                 </a:solidFill>
               </a:rPr>
-              <a:t>Source: bench/results/head-to-head-maros-meszaros-1860864.csv (1860864); bench/results/maros-meszaros-cad720c.csv (cad720c); bench/results/miplib-ad57c03.csv (ad57c03)</a:t>
+              <a:t>Source: bench/results/head-to-head-maros-meszaros-d0eb672.csv (d0eb672); bench/results/maros-meszaros-cad720c.csv (cad720c); bench/results/miplib-ad57c03.csv (ad57c03)</a:t>
             </a:r>
           </a:p>
         </p:txBody>
@@ -9049,7 +9049,7 @@
         </p:nvGraphicFramePr>
         <p:xfrm>
           <a:off x="457200" y="1645920"/>
-          <a:ext cx="6858000" cy="1920240"/>
+          <a:ext cx="6858000" cy="3200400"/>
         </p:xfrm>
         <a:graphic>
           <a:graphicData uri="http://schemas.openxmlformats.org/drawingml/2006/table">
@@ -9247,7 +9247,7 @@
                             <a:srgbClr val="555555"/>
                           </a:solidFill>
                         </a:rPr>
-                        <a:t>107</a:t>
+                        <a:t>119</a:t>
                       </a:r>
                     </a:p>
                   </a:txBody>
@@ -9268,7 +9268,7 @@
                             <a:srgbClr val="555555"/>
                           </a:solidFill>
                         </a:rPr>
-                        <a:t>106</a:t>
+                        <a:t>117</a:t>
                       </a:r>
                     </a:p>
                   </a:txBody>
@@ -9289,7 +9289,7 @@
                             <a:srgbClr val="555555"/>
                           </a:solidFill>
                         </a:rPr>
-                        <a:t>107</a:t>
+                        <a:t>119</a:t>
                       </a:r>
                     </a:p>
                   </a:txBody>
@@ -9310,7 +9310,7 @@
                             <a:srgbClr val="555555"/>
                           </a:solidFill>
                         </a:rPr>
-                        <a:t>6.437 s</a:t>
+                        <a:t>4.066 s</a:t>
                       </a:r>
                     </a:p>
                   </a:txBody>
@@ -9375,7 +9375,7 @@
                             <a:srgbClr val="555555"/>
                           </a:solidFill>
                         </a:rPr>
-                        <a:t>105</a:t>
+                        <a:t>102</a:t>
                       </a:r>
                     </a:p>
                   </a:txBody>
@@ -9396,7 +9396,7 @@
                             <a:srgbClr val="555555"/>
                           </a:solidFill>
                         </a:rPr>
-                        <a:t>99</a:t>
+                        <a:t>96</a:t>
                       </a:r>
                     </a:p>
                   </a:txBody>
@@ -9417,7 +9417,7 @@
                             <a:srgbClr val="555555"/>
                           </a:solidFill>
                         </a:rPr>
-                        <a:t>32</a:t>
+                        <a:t>31</a:t>
                       </a:r>
                     </a:p>
                   </a:txBody>
@@ -9438,7 +9438,7 @@
                             <a:srgbClr val="555555"/>
                           </a:solidFill>
                         </a:rPr>
-                        <a:t>35.781 s</a:t>
+                        <a:t>35.808 s</a:t>
                       </a:r>
                     </a:p>
                   </a:txBody>
@@ -9566,7 +9566,7 @@
                             <a:srgbClr val="555555"/>
                           </a:solidFill>
                         </a:rPr>
-                        <a:t>27.436 s</a:t>
+                        <a:t>26.584 s</a:t>
                       </a:r>
                     </a:p>
                   </a:txBody>
@@ -9631,7 +9631,7 @@
                             <a:srgbClr val="555555"/>
                           </a:solidFill>
                         </a:rPr>
-                        <a:t>127</a:t>
+                        <a:t>129</a:t>
                       </a:r>
                     </a:p>
                   </a:txBody>
@@ -9652,7 +9652,7 @@
                             <a:srgbClr val="555555"/>
                           </a:solidFill>
                         </a:rPr>
-                        <a:t>113</a:t>
+                        <a:t>115</a:t>
                       </a:r>
                     </a:p>
                   </a:txBody>
@@ -9673,7 +9673,7 @@
                             <a:srgbClr val="555555"/>
                           </a:solidFill>
                         </a:rPr>
-                        <a:t>62</a:t>
+                        <a:t>64</a:t>
                       </a:r>
                     </a:p>
                   </a:txBody>
@@ -9694,7 +9694,7 @@
                             <a:srgbClr val="555555"/>
                           </a:solidFill>
                         </a:rPr>
-                        <a:t>20.974 s</a:t>
+                        <a:t>20.001 s</a:t>
                       </a:r>
                     </a:p>
                   </a:txBody>
@@ -9823,6 +9823,518 @@
                           </a:solidFill>
                         </a:rPr>
                         <a:t>-</a:t>
+                      </a:r>
+                    </a:p>
+                  </a:txBody>
+                  <a:tcPr>
+                    <a:solidFill>
+                      <a:srgbClr val="FFFFFF"/>
+                    </a:solidFill>
+                  </a:tcPr>
+                </a:tc>
+              </a:tr>
+              <a:tr h="320040">
+                <a:tc>
+                  <a:txBody>
+                    <a:bodyPr/>
+                    <a:lstStyle/>
+                    <a:p>
+                      <a:r>
+                        <a:rPr sz="1200" b="0">
+                          <a:solidFill>
+                            <a:srgbClr val="555555"/>
+                          </a:solidFill>
+                        </a:rPr>
+                        <a:t>OSQP</a:t>
+                      </a:r>
+                    </a:p>
+                  </a:txBody>
+                  <a:tcPr>
+                    <a:solidFill>
+                      <a:srgbClr val="F2F4F7"/>
+                    </a:solidFill>
+                  </a:tcPr>
+                </a:tc>
+                <a:tc>
+                  <a:txBody>
+                    <a:bodyPr/>
+                    <a:lstStyle/>
+                    <a:p>
+                      <a:r>
+                        <a:rPr sz="1200" b="0">
+                          <a:solidFill>
+                            <a:srgbClr val="555555"/>
+                          </a:solidFill>
+                        </a:rPr>
+                        <a:t>138</a:t>
+                      </a:r>
+                    </a:p>
+                  </a:txBody>
+                  <a:tcPr>
+                    <a:solidFill>
+                      <a:srgbClr val="F2F4F7"/>
+                    </a:solidFill>
+                  </a:tcPr>
+                </a:tc>
+                <a:tc>
+                  <a:txBody>
+                    <a:bodyPr/>
+                    <a:lstStyle/>
+                    <a:p>
+                      <a:r>
+                        <a:rPr sz="1200" b="0">
+                          <a:solidFill>
+                            <a:srgbClr val="555555"/>
+                          </a:solidFill>
+                        </a:rPr>
+                        <a:t>65</a:t>
+                      </a:r>
+                    </a:p>
+                  </a:txBody>
+                  <a:tcPr>
+                    <a:solidFill>
+                      <a:srgbClr val="F2F4F7"/>
+                    </a:solidFill>
+                  </a:tcPr>
+                </a:tc>
+                <a:tc>
+                  <a:txBody>
+                    <a:bodyPr/>
+                    <a:lstStyle/>
+                    <a:p>
+                      <a:r>
+                        <a:rPr sz="1200" b="0">
+                          <a:solidFill>
+                            <a:srgbClr val="555555"/>
+                          </a:solidFill>
+                        </a:rPr>
+                        <a:t>61</a:t>
+                      </a:r>
+                    </a:p>
+                  </a:txBody>
+                  <a:tcPr>
+                    <a:solidFill>
+                      <a:srgbClr val="F2F4F7"/>
+                    </a:solidFill>
+                  </a:tcPr>
+                </a:tc>
+                <a:tc>
+                  <a:txBody>
+                    <a:bodyPr/>
+                    <a:lstStyle/>
+                    <a:p>
+                      <a:r>
+                        <a:rPr sz="1200" b="0">
+                          <a:solidFill>
+                            <a:srgbClr val="555555"/>
+                          </a:solidFill>
+                        </a:rPr>
+                        <a:t>48</a:t>
+                      </a:r>
+                    </a:p>
+                  </a:txBody>
+                  <a:tcPr>
+                    <a:solidFill>
+                      <a:srgbClr val="F2F4F7"/>
+                    </a:solidFill>
+                  </a:tcPr>
+                </a:tc>
+                <a:tc>
+                  <a:txBody>
+                    <a:bodyPr/>
+                    <a:lstStyle/>
+                    <a:p>
+                      <a:r>
+                        <a:rPr sz="1200" b="0">
+                          <a:solidFill>
+                            <a:srgbClr val="555555"/>
+                          </a:solidFill>
+                        </a:rPr>
+                        <a:t>26.650 s</a:t>
+                      </a:r>
+                    </a:p>
+                  </a:txBody>
+                  <a:tcPr>
+                    <a:solidFill>
+                      <a:srgbClr val="F2F4F7"/>
+                    </a:solidFill>
+                  </a:tcPr>
+                </a:tc>
+              </a:tr>
+              <a:tr h="320040">
+                <a:tc>
+                  <a:txBody>
+                    <a:bodyPr/>
+                    <a:lstStyle/>
+                    <a:p>
+                      <a:r>
+                        <a:rPr sz="1200" b="0">
+                          <a:solidFill>
+                            <a:srgbClr val="555555"/>
+                          </a:solidFill>
+                        </a:rPr>
+                        <a:t>Clarabel</a:t>
+                      </a:r>
+                    </a:p>
+                  </a:txBody>
+                  <a:tcPr>
+                    <a:solidFill>
+                      <a:srgbClr val="FFFFFF"/>
+                    </a:solidFill>
+                  </a:tcPr>
+                </a:tc>
+                <a:tc>
+                  <a:txBody>
+                    <a:bodyPr/>
+                    <a:lstStyle/>
+                    <a:p>
+                      <a:r>
+                        <a:rPr sz="1200" b="0">
+                          <a:solidFill>
+                            <a:srgbClr val="555555"/>
+                          </a:solidFill>
+                        </a:rPr>
+                        <a:t>138</a:t>
+                      </a:r>
+                    </a:p>
+                  </a:txBody>
+                  <a:tcPr>
+                    <a:solidFill>
+                      <a:srgbClr val="FFFFFF"/>
+                    </a:solidFill>
+                  </a:tcPr>
+                </a:tc>
+                <a:tc>
+                  <a:txBody>
+                    <a:bodyPr/>
+                    <a:lstStyle/>
+                    <a:p>
+                      <a:r>
+                        <a:rPr sz="1200" b="0">
+                          <a:solidFill>
+                            <a:srgbClr val="555555"/>
+                          </a:solidFill>
+                        </a:rPr>
+                        <a:t>132</a:t>
+                      </a:r>
+                    </a:p>
+                  </a:txBody>
+                  <a:tcPr>
+                    <a:solidFill>
+                      <a:srgbClr val="FFFFFF"/>
+                    </a:solidFill>
+                  </a:tcPr>
+                </a:tc>
+                <a:tc>
+                  <a:txBody>
+                    <a:bodyPr/>
+                    <a:lstStyle/>
+                    <a:p>
+                      <a:r>
+                        <a:rPr sz="1200" b="0">
+                          <a:solidFill>
+                            <a:srgbClr val="555555"/>
+                          </a:solidFill>
+                        </a:rPr>
+                        <a:t>105</a:t>
+                      </a:r>
+                    </a:p>
+                  </a:txBody>
+                  <a:tcPr>
+                    <a:solidFill>
+                      <a:srgbClr val="FFFFFF"/>
+                    </a:solidFill>
+                  </a:tcPr>
+                </a:tc>
+                <a:tc>
+                  <a:txBody>
+                    <a:bodyPr/>
+                    <a:lstStyle/>
+                    <a:p>
+                      <a:r>
+                        <a:rPr sz="1200" b="0">
+                          <a:solidFill>
+                            <a:srgbClr val="555555"/>
+                          </a:solidFill>
+                        </a:rPr>
+                        <a:t>107</a:t>
+                      </a:r>
+                    </a:p>
+                  </a:txBody>
+                  <a:tcPr>
+                    <a:solidFill>
+                      <a:srgbClr val="FFFFFF"/>
+                    </a:solidFill>
+                  </a:tcPr>
+                </a:tc>
+                <a:tc>
+                  <a:txBody>
+                    <a:bodyPr/>
+                    <a:lstStyle/>
+                    <a:p>
+                      <a:r>
+                        <a:rPr sz="1200" b="0">
+                          <a:solidFill>
+                            <a:srgbClr val="555555"/>
+                          </a:solidFill>
+                        </a:rPr>
+                        <a:t>10.062 s</a:t>
+                      </a:r>
+                    </a:p>
+                  </a:txBody>
+                  <a:tcPr>
+                    <a:solidFill>
+                      <a:srgbClr val="FFFFFF"/>
+                    </a:solidFill>
+                  </a:tcPr>
+                </a:tc>
+              </a:tr>
+              <a:tr h="320040">
+                <a:tc>
+                  <a:txBody>
+                    <a:bodyPr/>
+                    <a:lstStyle/>
+                    <a:p>
+                      <a:r>
+                        <a:rPr sz="1200" b="0">
+                          <a:solidFill>
+                            <a:srgbClr val="555555"/>
+                          </a:solidFill>
+                        </a:rPr>
+                        <a:t>PIQP</a:t>
+                      </a:r>
+                    </a:p>
+                  </a:txBody>
+                  <a:tcPr>
+                    <a:solidFill>
+                      <a:srgbClr val="F2F4F7"/>
+                    </a:solidFill>
+                  </a:tcPr>
+                </a:tc>
+                <a:tc>
+                  <a:txBody>
+                    <a:bodyPr/>
+                    <a:lstStyle/>
+                    <a:p>
+                      <a:r>
+                        <a:rPr sz="1200" b="0">
+                          <a:solidFill>
+                            <a:srgbClr val="555555"/>
+                          </a:solidFill>
+                        </a:rPr>
+                        <a:t>138</a:t>
+                      </a:r>
+                    </a:p>
+                  </a:txBody>
+                  <a:tcPr>
+                    <a:solidFill>
+                      <a:srgbClr val="F2F4F7"/>
+                    </a:solidFill>
+                  </a:tcPr>
+                </a:tc>
+                <a:tc>
+                  <a:txBody>
+                    <a:bodyPr/>
+                    <a:lstStyle/>
+                    <a:p>
+                      <a:r>
+                        <a:rPr sz="1200" b="0">
+                          <a:solidFill>
+                            <a:srgbClr val="555555"/>
+                          </a:solidFill>
+                        </a:rPr>
+                        <a:t>137</a:t>
+                      </a:r>
+                    </a:p>
+                  </a:txBody>
+                  <a:tcPr>
+                    <a:solidFill>
+                      <a:srgbClr val="F2F4F7"/>
+                    </a:solidFill>
+                  </a:tcPr>
+                </a:tc>
+                <a:tc>
+                  <a:txBody>
+                    <a:bodyPr/>
+                    <a:lstStyle/>
+                    <a:p>
+                      <a:r>
+                        <a:rPr sz="1200" b="0">
+                          <a:solidFill>
+                            <a:srgbClr val="555555"/>
+                          </a:solidFill>
+                        </a:rPr>
+                        <a:t>130</a:t>
+                      </a:r>
+                    </a:p>
+                  </a:txBody>
+                  <a:tcPr>
+                    <a:solidFill>
+                      <a:srgbClr val="F2F4F7"/>
+                    </a:solidFill>
+                  </a:tcPr>
+                </a:tc>
+                <a:tc>
+                  <a:txBody>
+                    <a:bodyPr/>
+                    <a:lstStyle/>
+                    <a:p>
+                      <a:r>
+                        <a:rPr sz="1200" b="0">
+                          <a:solidFill>
+                            <a:srgbClr val="555555"/>
+                          </a:solidFill>
+                        </a:rPr>
+                        <a:t>135</a:t>
+                      </a:r>
+                    </a:p>
+                  </a:txBody>
+                  <a:tcPr>
+                    <a:solidFill>
+                      <a:srgbClr val="F2F4F7"/>
+                    </a:solidFill>
+                  </a:tcPr>
+                </a:tc>
+                <a:tc>
+                  <a:txBody>
+                    <a:bodyPr/>
+                    <a:lstStyle/>
+                    <a:p>
+                      <a:r>
+                        <a:rPr sz="1200" b="0">
+                          <a:solidFill>
+                            <a:srgbClr val="555555"/>
+                          </a:solidFill>
+                        </a:rPr>
+                        <a:t>1.905 s</a:t>
+                      </a:r>
+                    </a:p>
+                  </a:txBody>
+                  <a:tcPr>
+                    <a:solidFill>
+                      <a:srgbClr val="F2F4F7"/>
+                    </a:solidFill>
+                  </a:tcPr>
+                </a:tc>
+              </a:tr>
+              <a:tr h="320040">
+                <a:tc>
+                  <a:txBody>
+                    <a:bodyPr/>
+                    <a:lstStyle/>
+                    <a:p>
+                      <a:r>
+                        <a:rPr sz="1200" b="0">
+                          <a:solidFill>
+                            <a:srgbClr val="555555"/>
+                          </a:solidFill>
+                        </a:rPr>
+                        <a:t>SCS</a:t>
+                      </a:r>
+                    </a:p>
+                  </a:txBody>
+                  <a:tcPr>
+                    <a:solidFill>
+                      <a:srgbClr val="FFFFFF"/>
+                    </a:solidFill>
+                  </a:tcPr>
+                </a:tc>
+                <a:tc>
+                  <a:txBody>
+                    <a:bodyPr/>
+                    <a:lstStyle/>
+                    <a:p>
+                      <a:r>
+                        <a:rPr sz="1200" b="0">
+                          <a:solidFill>
+                            <a:srgbClr val="555555"/>
+                          </a:solidFill>
+                        </a:rPr>
+                        <a:t>138</a:t>
+                      </a:r>
+                    </a:p>
+                  </a:txBody>
+                  <a:tcPr>
+                    <a:solidFill>
+                      <a:srgbClr val="FFFFFF"/>
+                    </a:solidFill>
+                  </a:tcPr>
+                </a:tc>
+                <a:tc>
+                  <a:txBody>
+                    <a:bodyPr/>
+                    <a:lstStyle/>
+                    <a:p>
+                      <a:r>
+                        <a:rPr sz="1200" b="0">
+                          <a:solidFill>
+                            <a:srgbClr val="555555"/>
+                          </a:solidFill>
+                        </a:rPr>
+                        <a:t>125</a:t>
+                      </a:r>
+                    </a:p>
+                  </a:txBody>
+                  <a:tcPr>
+                    <a:solidFill>
+                      <a:srgbClr val="FFFFFF"/>
+                    </a:solidFill>
+                  </a:tcPr>
+                </a:tc>
+                <a:tc>
+                  <a:txBody>
+                    <a:bodyPr/>
+                    <a:lstStyle/>
+                    <a:p>
+                      <a:r>
+                        <a:rPr sz="1200" b="0">
+                          <a:solidFill>
+                            <a:srgbClr val="555555"/>
+                          </a:solidFill>
+                        </a:rPr>
+                        <a:t>105</a:t>
+                      </a:r>
+                    </a:p>
+                  </a:txBody>
+                  <a:tcPr>
+                    <a:solidFill>
+                      <a:srgbClr val="FFFFFF"/>
+                    </a:solidFill>
+                  </a:tcPr>
+                </a:tc>
+                <a:tc>
+                  <a:txBody>
+                    <a:bodyPr/>
+                    <a:lstStyle/>
+                    <a:p>
+                      <a:r>
+                        <a:rPr sz="1200" b="0">
+                          <a:solidFill>
+                            <a:srgbClr val="555555"/>
+                          </a:solidFill>
+                        </a:rPr>
+                        <a:t>72</a:t>
+                      </a:r>
+                    </a:p>
+                  </a:txBody>
+                  <a:tcPr>
+                    <a:solidFill>
+                      <a:srgbClr val="FFFFFF"/>
+                    </a:solidFill>
+                  </a:tcPr>
+                </a:tc>
+                <a:tc>
+                  <a:txBody>
+                    <a:bodyPr/>
+                    <a:lstStyle/>
+                    <a:p>
+                      <a:r>
+                        <a:rPr sz="1200" b="0">
+                          <a:solidFill>
+                            <a:srgbClr val="555555"/>
+                          </a:solidFill>
+                        </a:rPr>
+                        <a:t>16.235 s</a:t>
                       </a:r>
                     </a:p>
                   </a:txBody>
@@ -9870,7 +10382,7 @@
                   <a:srgbClr val="555555"/>
                 </a:solidFill>
               </a:rPr>
-              <a:t>A rival's optimal status is not taken on trust either: the verifier rejected 163 rival QP answers in this run, and only verified runs count for time. Against HiGHS instance by instance: faster on 82, tie on 22, slower on 5 of 109.</a:t>
+              <a:t>A rival's optimal status is not taken on trust either: the verifier rejected 258 rival QP answers in this run, and only verified runs count for time. Against HiGHS instance by instance: faster on 91, tie on 26, slower on 3 of 120.</a:t>
             </a:r>
           </a:p>
           <a:p>

</xml_diff>